<commit_message>
Update presentation file for Ackermann model trajectory control
</commit_message>
<xml_diff>
--- a/presentacion/Robot_Movil_Ackermann_Modelo_Trayectoria_Control.pptx
+++ b/presentacion/Robot_Movil_Ackermann_Modelo_Trayectoria_Control.pptx
@@ -5518,7 +5518,7 @@
                 </a:solidFill>
                 <a:latin typeface="Calibri"/>
               </a:rPr>
-              <a:t>Material de cátedra  ·  Robótica y Sistemas de Control  ·  Ing. Juan P. Pedroni  ·  Mayo 2026</a:t>
+              <a:t>Material de cátedra  ·  Robótica y Sistemas de Control  ·  Ing. Juan P. Pedroni  ·  Julio 2026</a:t>
             </a:r>
           </a:p>
         </p:txBody>
@@ -12313,13 +12313,13 @@
               </a:spcAft>
             </a:pPr>
             <a:r>
-              <a:rPr sz="1250">
+              <a:rPr sz="1100">
                 <a:solidFill>
                   <a:srgbClr val="1D3557"/>
                 </a:solidFill>
                 <a:latin typeface="Consolas"/>
               </a:rPr>
-              <a:t># main_rs.py  ·  delta_s definido una vez:</a:t>
+              <a:t xml:space="preserve"># main_rs.py  ·  Euler explicito  ·  por segmento (1 vez):</a:t>
             </a:r>
           </a:p>
           <a:p>
@@ -12335,13 +12335,13 @@
               </a:spcAft>
             </a:pPr>
             <a:r>
-              <a:rPr sz="1250">
+              <a:rPr sz="1100">
                 <a:solidFill>
                   <a:srgbClr val="1D3557"/>
                 </a:solidFill>
                 <a:latin typeface="Consolas"/>
               </a:rPr>
-              <a:t>delta_s = h * v / 1000.0   # avance por tick (h=1ms, v=39cm/s)</a:t>
+              <a:t xml:space="preserve">delta_s = h * v / 1000.0       # avance por tick (h=1ms)</a:t>
             </a:r>
           </a:p>
           <a:p>
@@ -12357,13 +12357,13 @@
               </a:spcAft>
             </a:pPr>
             <a:r>
-              <a:rPr sz="1250">
+              <a:rPr sz="1100">
                 <a:solidFill>
                   <a:srgbClr val="1D3557"/>
                 </a:solidFill>
                 <a:latin typeface="Consolas"/>
               </a:rPr>
-              <a:t> </a:t>
+              <a:t xml:space="preserve">N_seg   = ceil(distance / delta_s)     # ticks enteros</a:t>
             </a:r>
           </a:p>
           <a:p>
@@ -12379,13 +12379,13 @@
               </a:spcAft>
             </a:pPr>
             <a:r>
-              <a:rPr sz="1250">
+              <a:rPr sz="1100">
                 <a:solidFill>
                   <a:srgbClr val="1D3557"/>
                 </a:solidFill>
                 <a:latin typeface="Consolas"/>
               </a:rPr>
-              <a:t># ... dentro del lazo, en cada iteracion: ...</a:t>
+              <a:t xml:space="preserve">ds_seg  = distance / N_seg     # paso que cierra justo</a:t>
             </a:r>
           </a:p>
           <a:p>
@@ -12401,13 +12401,13 @@
               </a:spcAft>
             </a:pPr>
             <a:r>
-              <a:rPr sz="1250">
+              <a:rPr sz="1100">
                 <a:solidFill>
                   <a:srgbClr val="1D3557"/>
                 </a:solidFill>
                 <a:latin typeface="Consolas"/>
               </a:rPr>
-              <a:t> </a:t>
+              <a:t xml:space="preserve">head0   = steering_reference   # rumbo al entrar al tramo</a:t>
             </a:r>
           </a:p>
           <a:p>
@@ -12423,13 +12423,13 @@
               </a:spcAft>
             </a:pPr>
             <a:r>
-              <a:rPr sz="1250">
+              <a:rPr sz="1100">
                 <a:solidFill>
                   <a:srgbClr val="1D3557"/>
                 </a:solidFill>
                 <a:latin typeface="Consolas"/>
               </a:rPr>
-              <a:t># las referencias avanzan juntas, solo mientras</a:t>
+              <a:t xml:space="preserve"> </a:t>
             </a:r>
           </a:p>
           <a:p>
@@ -12445,13 +12445,13 @@
               </a:spcAft>
             </a:pPr>
             <a:r>
-              <a:rPr sz="1250">
+              <a:rPr sz="1100">
                 <a:solidFill>
                   <a:srgbClr val="1D3557"/>
                 </a:solidFill>
                 <a:latin typeface="Consolas"/>
               </a:rPr>
-              <a:t># la referencia no llego al final del tramo</a:t>
+              <a:t xml:space="preserve"># ... dentro del lazo, en cada tick: ...</a:t>
             </a:r>
           </a:p>
           <a:p>
@@ -12467,13 +12467,13 @@
               </a:spcAft>
             </a:pPr>
             <a:r>
-              <a:rPr sz="1250">
+              <a:rPr sz="1100">
                 <a:solidFill>
                   <a:srgbClr val="1D3557"/>
                 </a:solidFill>
                 <a:latin typeface="Consolas"/>
               </a:rPr>
-              <a:t>if abs(position_reference) &lt; abs(distance):</a:t>
+              <a:t xml:space="preserve">if ref_ticks &lt; N_seg:</a:t>
             </a:r>
           </a:p>
           <a:p>
@@ -12489,13 +12489,13 @@
               </a:spcAft>
             </a:pPr>
             <a:r>
-              <a:rPr sz="1250">
+              <a:rPr sz="1100">
                 <a:solidFill>
                   <a:srgbClr val="1D3557"/>
                 </a:solidFill>
                 <a:latin typeface="Consolas"/>
               </a:rPr>
-              <a:t>    position_reference += gear * delta_s</a:t>
+              <a:t xml:space="preserve">    ref_ticks += 1</a:t>
             </a:r>
           </a:p>
           <a:p>
@@ -12511,13 +12511,13 @@
               </a:spcAft>
             </a:pPr>
             <a:r>
-              <a:rPr sz="1250">
+              <a:rPr sz="1100">
                 <a:solidFill>
                   <a:srgbClr val="1D3557"/>
                 </a:solidFill>
                 <a:latin typeface="Consolas"/>
               </a:rPr>
-              <a:t>    steering_reference += gear * steer_dir * delta_s / r_turn_min</a:t>
+              <a:t xml:space="preserve">    if ref_ticks &lt; N_seg:          # avanza ds_seg exacto</a:t>
             </a:r>
           </a:p>
           <a:p>
@@ -12533,13 +12533,13 @@
               </a:spcAft>
             </a:pPr>
             <a:r>
-              <a:rPr sz="1250">
+              <a:rPr sz="1100">
                 <a:solidFill>
                   <a:srgbClr val="1D3557"/>
                 </a:solidFill>
                 <a:latin typeface="Consolas"/>
               </a:rPr>
-              <a:t> </a:t>
+              <a:t xml:space="preserve">        position_reference += gear * ds_seg</a:t>
             </a:r>
           </a:p>
           <a:p>
@@ -12555,13 +12555,13 @@
               </a:spcAft>
             </a:pPr>
             <a:r>
-              <a:rPr sz="1250">
+              <a:rPr sz="1100">
                 <a:solidFill>
                   <a:srgbClr val="1D3557"/>
                 </a:solidFill>
                 <a:latin typeface="Consolas"/>
               </a:rPr>
-              <a:t>#   r_pos  : integra el ARCO recorrido</a:t>
+              <a:t xml:space="preserve">        steering_reference += gear * steer_dir * ds_seg / r_turn_min</a:t>
             </a:r>
           </a:p>
           <a:p>
@@ -12577,13 +12577,57 @@
               </a:spcAft>
             </a:pPr>
             <a:r>
-              <a:rPr sz="1250">
+              <a:rPr sz="1100">
                 <a:solidFill>
                   <a:srgbClr val="1D3557"/>
                 </a:solidFill>
                 <a:latin typeface="Consolas"/>
               </a:rPr>
-              <a:t>#   r_head : integra el RUMBO  (d-theta = ds / R)</a:t>
+              <a:t xml:space="preserve">    else:                          # ultimo tick: fija el fin</a:t>
+            </a:r>
+          </a:p>
+          <a:p>
+            <a:pPr>
+              <a:lnSpc>
+                <a:spcPct val="100000"/>
+              </a:lnSpc>
+              <a:spcBef>
+                <a:spcPts val="0"/>
+              </a:spcBef>
+              <a:spcAft>
+                <a:spcPts val="0"/>
+              </a:spcAft>
+            </a:pPr>
+            <a:r>
+              <a:rPr sz="1100">
+                <a:solidFill>
+                  <a:srgbClr val="1D3557"/>
+                </a:solidFill>
+                <a:latin typeface="Consolas"/>
+              </a:rPr>
+              <a:t xml:space="preserve">        position_reference = gear * distance</a:t>
+            </a:r>
+          </a:p>
+          <a:p>
+            <a:pPr>
+              <a:lnSpc>
+                <a:spcPct val="100000"/>
+              </a:lnSpc>
+              <a:spcBef>
+                <a:spcPts val="0"/>
+              </a:spcBef>
+              <a:spcAft>
+                <a:spcPts val="0"/>
+              </a:spcAft>
+            </a:pPr>
+            <a:r>
+              <a:rPr sz="1100">
+                <a:solidFill>
+                  <a:srgbClr val="1D3557"/>
+                </a:solidFill>
+                <a:latin typeface="Consolas"/>
+              </a:rPr>
+              <a:t xml:space="preserve">        steering_reference = head0 + gear*steer_dir*distance/r_turn_min</a:t>
             </a:r>
           </a:p>
         </p:txBody>
@@ -12628,7 +12672,7 @@
                 </a:solidFill>
                 <a:latin typeface="Calibri"/>
               </a:rPr>
-              <a:t>El generador de referencias completo: dos integradores discretos dentro del mismo lazo de control.</a:t>
+              <a:t>El generador de referencias: dos integradores de Euler discretos dentro del mismo lazo de control.</a:t>
             </a:r>
           </a:p>
         </p:txBody>
@@ -12682,7 +12726,38 @@
                 </a:solidFill>
                 <a:latin typeface="Calibri"/>
               </a:rPr>
-              <a:t>Cada tick (1 ms) la referencia avanza Δs = h·v/1000.</a:t>
+              <a:t>El estado se integra por el método de Euler explícito, con paso fijo h (el período del timer).</a:t>
+            </a:r>
+          </a:p>
+          <a:p>
+            <a:pPr marL="0" indent="0">
+              <a:lnSpc>
+                <a:spcPct val="105000"/>
+              </a:lnSpc>
+              <a:spcBef>
+                <a:spcPts val="600"/>
+              </a:spcBef>
+              <a:spcAft>
+                <a:spcPts val="0"/>
+              </a:spcAft>
+            </a:pPr>
+            <a:r>
+              <a:rPr sz="1450" b="1">
+                <a:solidFill>
+                  <a:srgbClr val="2C6E8F"/>
+                </a:solidFill>
+                <a:latin typeface="Calibri"/>
+              </a:rPr>
+              <a:t>▪  </a:t>
+            </a:r>
+            <a:r>
+              <a:rPr sz="1450" b="0">
+                <a:solidFill>
+                  <a:srgbClr val="243441"/>
+                </a:solidFill>
+                <a:latin typeface="Calibri"/>
+              </a:rPr>
+              <a:t>El tramo se cuantiza en N = ceil(distancia / Δs) ticks enteros del timer.</a:t>
             </a:r>
           </a:p>
           <a:p>
@@ -12713,7 +12788,7 @@
                 </a:solidFill>
                 <a:latin typeface="Calibri"/>
               </a:rPr>
-              <a:t>r_pos integra distancia; gear da el signo (adelante o marcha atrás).</a:t>
+              <a:t>El paso de arco se recalcula ds = distancia / N: cae exacto al final del tramo.</a:t>
             </a:r>
           </a:p>
           <a:p>
@@ -12744,7 +12819,7 @@
                 </a:solidFill>
                 <a:latin typeface="Calibri"/>
               </a:rPr>
-              <a:t>r_head integra rumbo: relación cinemática dθ = ds/R, con R = r_turn_min.</a:t>
+              <a:t>r_pos integra distancia; r_head integra rumbo (dθ = ds/R, R = r_turn_min). gear da el signo.</a:t>
             </a:r>
           </a:p>
           <a:p>
@@ -12806,7 +12881,7 @@
                 </a:solidFill>
                 <a:latin typeface="Calibri"/>
               </a:rPr>
-              <a:t>Al terminar el tramo, la compuerta if … &lt; distance deja la referencia quieta esperando al auto.</a:t>
+              <a:t>El último tick fija la referencia en el valor exacto: sin overshoot ni deriva de rumbo entre tramos.</a:t>
             </a:r>
           </a:p>
         </p:txBody>
@@ -21567,6 +21642,68 @@
                 <a:latin typeface="Calibri"/>
               </a:rPr>
               <a:t>Sin evitación de obstáculos: el planificador asume el espacio libre.</a:t>
+            </a:r>
+          </a:p>
+          <a:p>
+            <a:pPr marL="0" indent="0">
+              <a:lnSpc>
+                <a:spcPct val="112000"/>
+              </a:lnSpc>
+              <a:spcBef>
+                <a:spcPts val="0"/>
+              </a:spcBef>
+              <a:spcAft>
+                <a:spcPts val="700"/>
+              </a:spcAft>
+            </a:pPr>
+            <a:r>
+              <a:rPr sz="1500" b="1">
+                <a:solidFill>
+                  <a:srgbClr val="2C6E8F"/>
+                </a:solidFill>
+                <a:latin typeface="Calibri"/>
+              </a:rPr>
+              <a:t>▪  </a:t>
+            </a:r>
+            <a:r>
+              <a:rPr sz="1500" b="0" i="0">
+                <a:solidFill>
+                  <a:srgbClr val="243441"/>
+                </a:solidFill>
+                <a:latin typeface="Calibri"/>
+              </a:rPr>
+              <a:t>Seguimiento de pose con cross-track y feedforward de curvatura: hoy el lazo de rumbo no corrige el desvío lateral respecto de la traza.</a:t>
+            </a:r>
+          </a:p>
+          <a:p>
+            <a:pPr marL="0" indent="0">
+              <a:lnSpc>
+                <a:spcPct val="112000"/>
+              </a:lnSpc>
+              <a:spcBef>
+                <a:spcPts val="0"/>
+              </a:spcBef>
+              <a:spcAft>
+                <a:spcPts val="700"/>
+              </a:spcAft>
+            </a:pPr>
+            <a:r>
+              <a:rPr sz="1500" b="1">
+                <a:solidFill>
+                  <a:srgbClr val="2C6E8F"/>
+                </a:solidFill>
+                <a:latin typeface="Calibri"/>
+              </a:rPr>
+              <a:t>▪  </a:t>
+            </a:r>
+            <a:r>
+              <a:rPr sz="1500" b="0" i="0">
+                <a:solidFill>
+                  <a:srgbClr val="243441"/>
+                </a:solidFill>
+                <a:latin typeface="Calibri"/>
+              </a:rPr>
+              <a:t>Tracción en cascada (posición → velocidad → motor): hoy el comando es potencia y la velocidad efectiva varía con la carga y la batería.</a:t>
             </a:r>
           </a:p>
         </p:txBody>

</xml_diff>